<commit_message>
teleport and arm weapon system
</commit_message>
<xml_diff>
--- a/docs/use_cases.pptx
+++ b/docs/use_cases.pptx
@@ -1572,10 +1572,102 @@
   <pc:docChgLst>
     <pc:chgData name="Jan Novak" userId="1a56226553c618a2" providerId="LiveId" clId="{E3B4918E-38CB-464C-BBE3-464D048D27BA}"/>
     <pc:docChg chg="undo custSel modSld">
-      <pc:chgData name="Jan Novak" userId="1a56226553c618a2" providerId="LiveId" clId="{E3B4918E-38CB-464C-BBE3-464D048D27BA}" dt="2021-08-06T12:25:27.901" v="523" actId="14100"/>
+      <pc:chgData name="Jan Novak" userId="1a56226553c618a2" providerId="LiveId" clId="{E3B4918E-38CB-464C-BBE3-464D048D27BA}" dt="2021-08-23T14:01:18.724" v="570" actId="20577"/>
       <pc:docMkLst>
         <pc:docMk/>
       </pc:docMkLst>
+      <pc:sldChg chg="modSp mod">
+        <pc:chgData name="Jan Novak" userId="1a56226553c618a2" providerId="LiveId" clId="{E3B4918E-38CB-464C-BBE3-464D048D27BA}" dt="2021-08-23T13:58:52.860" v="556" actId="20577"/>
+        <pc:sldMkLst>
+          <pc:docMk/>
+          <pc:sldMk cId="2995428109" sldId="257"/>
+        </pc:sldMkLst>
+        <pc:spChg chg="mod">
+          <ac:chgData name="Jan Novak" userId="1a56226553c618a2" providerId="LiveId" clId="{E3B4918E-38CB-464C-BBE3-464D048D27BA}" dt="2021-08-23T13:58:52.860" v="556" actId="20577"/>
+          <ac:spMkLst>
+            <pc:docMk/>
+            <pc:sldMk cId="2995428109" sldId="257"/>
+            <ac:spMk id="72" creationId="{14256460-766F-4150-AF9C-7E01C0D0CF7E}"/>
+          </ac:spMkLst>
+        </pc:spChg>
+        <pc:spChg chg="mod">
+          <ac:chgData name="Jan Novak" userId="1a56226553c618a2" providerId="LiveId" clId="{E3B4918E-38CB-464C-BBE3-464D048D27BA}" dt="2021-08-23T13:58:00.469" v="526" actId="20577"/>
+          <ac:spMkLst>
+            <pc:docMk/>
+            <pc:sldMk cId="2995428109" sldId="257"/>
+            <ac:spMk id="73" creationId="{3EC58F03-54DF-42F1-97EE-657F7B7E155E}"/>
+          </ac:spMkLst>
+        </pc:spChg>
+        <pc:cxnChg chg="mod">
+          <ac:chgData name="Jan Novak" userId="1a56226553c618a2" providerId="LiveId" clId="{E3B4918E-38CB-464C-BBE3-464D048D27BA}" dt="2021-08-23T13:58:32.007" v="530" actId="1076"/>
+          <ac:cxnSpMkLst>
+            <pc:docMk/>
+            <pc:sldMk cId="2995428109" sldId="257"/>
+            <ac:cxnSpMk id="71" creationId="{EDD74C6F-676D-40EA-8988-86AE11A6FFE8}"/>
+          </ac:cxnSpMkLst>
+        </pc:cxnChg>
+      </pc:sldChg>
+      <pc:sldChg chg="modSp mod">
+        <pc:chgData name="Jan Novak" userId="1a56226553c618a2" providerId="LiveId" clId="{E3B4918E-38CB-464C-BBE3-464D048D27BA}" dt="2021-08-23T13:59:28.740" v="560" actId="20577"/>
+        <pc:sldMkLst>
+          <pc:docMk/>
+          <pc:sldMk cId="3073215809" sldId="258"/>
+        </pc:sldMkLst>
+        <pc:spChg chg="mod">
+          <ac:chgData name="Jan Novak" userId="1a56226553c618a2" providerId="LiveId" clId="{E3B4918E-38CB-464C-BBE3-464D048D27BA}" dt="2021-08-23T13:59:14.846" v="557" actId="20577"/>
+          <ac:spMkLst>
+            <pc:docMk/>
+            <pc:sldMk cId="3073215809" sldId="258"/>
+            <ac:spMk id="70" creationId="{D8EA0498-99C0-491E-98C4-D04AA98FDB46}"/>
+          </ac:spMkLst>
+        </pc:spChg>
+        <pc:spChg chg="mod">
+          <ac:chgData name="Jan Novak" userId="1a56226553c618a2" providerId="LiveId" clId="{E3B4918E-38CB-464C-BBE3-464D048D27BA}" dt="2021-08-23T13:59:28.740" v="560" actId="20577"/>
+          <ac:spMkLst>
+            <pc:docMk/>
+            <pc:sldMk cId="3073215809" sldId="258"/>
+            <ac:spMk id="73" creationId="{3EC58F03-54DF-42F1-97EE-657F7B7E155E}"/>
+          </ac:spMkLst>
+        </pc:spChg>
+      </pc:sldChg>
+      <pc:sldChg chg="modSp mod">
+        <pc:chgData name="Jan Novak" userId="1a56226553c618a2" providerId="LiveId" clId="{E3B4918E-38CB-464C-BBE3-464D048D27BA}" dt="2021-08-23T14:01:10.178" v="567" actId="20577"/>
+        <pc:sldMkLst>
+          <pc:docMk/>
+          <pc:sldMk cId="2282750098" sldId="259"/>
+        </pc:sldMkLst>
+        <pc:spChg chg="mod">
+          <ac:chgData name="Jan Novak" userId="1a56226553c618a2" providerId="LiveId" clId="{E3B4918E-38CB-464C-BBE3-464D048D27BA}" dt="2021-08-23T14:01:10.178" v="567" actId="20577"/>
+          <ac:spMkLst>
+            <pc:docMk/>
+            <pc:sldMk cId="2282750098" sldId="259"/>
+            <ac:spMk id="73" creationId="{3EC58F03-54DF-42F1-97EE-657F7B7E155E}"/>
+          </ac:spMkLst>
+        </pc:spChg>
+      </pc:sldChg>
+      <pc:sldChg chg="modSp mod">
+        <pc:chgData name="Jan Novak" userId="1a56226553c618a2" providerId="LiveId" clId="{E3B4918E-38CB-464C-BBE3-464D048D27BA}" dt="2021-08-23T14:00:00.061" v="564" actId="20577"/>
+        <pc:sldMkLst>
+          <pc:docMk/>
+          <pc:sldMk cId="734554990" sldId="260"/>
+        </pc:sldMkLst>
+        <pc:spChg chg="mod">
+          <ac:chgData name="Jan Novak" userId="1a56226553c618a2" providerId="LiveId" clId="{E3B4918E-38CB-464C-BBE3-464D048D27BA}" dt="2021-08-23T14:00:00.061" v="564" actId="20577"/>
+          <ac:spMkLst>
+            <pc:docMk/>
+            <pc:sldMk cId="734554990" sldId="260"/>
+            <ac:spMk id="70" creationId="{D8EA0498-99C0-491E-98C4-D04AA98FDB46}"/>
+          </ac:spMkLst>
+        </pc:spChg>
+        <pc:spChg chg="mod">
+          <ac:chgData name="Jan Novak" userId="1a56226553c618a2" providerId="LiveId" clId="{E3B4918E-38CB-464C-BBE3-464D048D27BA}" dt="2021-08-23T13:59:57.437" v="563" actId="20577"/>
+          <ac:spMkLst>
+            <pc:docMk/>
+            <pc:sldMk cId="734554990" sldId="260"/>
+            <ac:spMk id="73" creationId="{3EC58F03-54DF-42F1-97EE-657F7B7E155E}"/>
+          </ac:spMkLst>
+        </pc:spChg>
+      </pc:sldChg>
       <pc:sldChg chg="addSp delSp modSp mod">
         <pc:chgData name="Jan Novak" userId="1a56226553c618a2" providerId="LiveId" clId="{E3B4918E-38CB-464C-BBE3-464D048D27BA}" dt="2021-08-06T12:25:27.901" v="523" actId="14100"/>
         <pc:sldMkLst>
@@ -1960,6 +2052,21 @@
         </pc:cxnChg>
       </pc:sldChg>
       <pc:sldChg chg="modSp mod">
+        <pc:chgData name="Jan Novak" userId="1a56226553c618a2" providerId="LiveId" clId="{E3B4918E-38CB-464C-BBE3-464D048D27BA}" dt="2021-08-23T14:01:18.724" v="570" actId="20577"/>
+        <pc:sldMkLst>
+          <pc:docMk/>
+          <pc:sldMk cId="2074183465" sldId="265"/>
+        </pc:sldMkLst>
+        <pc:spChg chg="mod">
+          <ac:chgData name="Jan Novak" userId="1a56226553c618a2" providerId="LiveId" clId="{E3B4918E-38CB-464C-BBE3-464D048D27BA}" dt="2021-08-23T14:01:18.724" v="570" actId="20577"/>
+          <ac:spMkLst>
+            <pc:docMk/>
+            <pc:sldMk cId="2074183465" sldId="265"/>
+            <ac:spMk id="73" creationId="{3EC58F03-54DF-42F1-97EE-657F7B7E155E}"/>
+          </ac:spMkLst>
+        </pc:spChg>
+      </pc:sldChg>
+      <pc:sldChg chg="modSp mod">
         <pc:chgData name="Jan Novak" userId="1a56226553c618a2" providerId="LiveId" clId="{E3B4918E-38CB-464C-BBE3-464D048D27BA}" dt="2021-07-22T10:38:15.185" v="93" actId="27636"/>
         <pc:sldMkLst>
           <pc:docMk/>
@@ -2299,7 +2406,7 @@
           <a:p>
             <a:fld id="{048E75BA-ABDE-473E-A6C9-CE8F4F15D8F3}" type="datetimeFigureOut">
               <a:rPr lang="en-US" smtClean="0"/>
-              <a:t>8/6/2021</a:t>
+              <a:t>8/23/2021</a:t>
             </a:fld>
             <a:endParaRPr lang="en-US"/>
           </a:p>
@@ -2497,7 +2604,7 @@
           <a:p>
             <a:fld id="{048E75BA-ABDE-473E-A6C9-CE8F4F15D8F3}" type="datetimeFigureOut">
               <a:rPr lang="en-US" smtClean="0"/>
-              <a:t>8/6/2021</a:t>
+              <a:t>8/23/2021</a:t>
             </a:fld>
             <a:endParaRPr lang="en-US"/>
           </a:p>
@@ -2705,7 +2812,7 @@
           <a:p>
             <a:fld id="{048E75BA-ABDE-473E-A6C9-CE8F4F15D8F3}" type="datetimeFigureOut">
               <a:rPr lang="en-US" smtClean="0"/>
-              <a:t>8/6/2021</a:t>
+              <a:t>8/23/2021</a:t>
             </a:fld>
             <a:endParaRPr lang="en-US"/>
           </a:p>
@@ -2903,7 +3010,7 @@
           <a:p>
             <a:fld id="{048E75BA-ABDE-473E-A6C9-CE8F4F15D8F3}" type="datetimeFigureOut">
               <a:rPr lang="en-US" smtClean="0"/>
-              <a:t>8/6/2021</a:t>
+              <a:t>8/23/2021</a:t>
             </a:fld>
             <a:endParaRPr lang="en-US"/>
           </a:p>
@@ -3178,7 +3285,7 @@
           <a:p>
             <a:fld id="{048E75BA-ABDE-473E-A6C9-CE8F4F15D8F3}" type="datetimeFigureOut">
               <a:rPr lang="en-US" smtClean="0"/>
-              <a:t>8/6/2021</a:t>
+              <a:t>8/23/2021</a:t>
             </a:fld>
             <a:endParaRPr lang="en-US"/>
           </a:p>
@@ -3443,7 +3550,7 @@
           <a:p>
             <a:fld id="{048E75BA-ABDE-473E-A6C9-CE8F4F15D8F3}" type="datetimeFigureOut">
               <a:rPr lang="en-US" smtClean="0"/>
-              <a:t>8/6/2021</a:t>
+              <a:t>8/23/2021</a:t>
             </a:fld>
             <a:endParaRPr lang="en-US"/>
           </a:p>
@@ -3855,7 +3962,7 @@
           <a:p>
             <a:fld id="{048E75BA-ABDE-473E-A6C9-CE8F4F15D8F3}" type="datetimeFigureOut">
               <a:rPr lang="en-US" smtClean="0"/>
-              <a:t>8/6/2021</a:t>
+              <a:t>8/23/2021</a:t>
             </a:fld>
             <a:endParaRPr lang="en-US"/>
           </a:p>
@@ -3996,7 +4103,7 @@
           <a:p>
             <a:fld id="{048E75BA-ABDE-473E-A6C9-CE8F4F15D8F3}" type="datetimeFigureOut">
               <a:rPr lang="en-US" smtClean="0"/>
-              <a:t>8/6/2021</a:t>
+              <a:t>8/23/2021</a:t>
             </a:fld>
             <a:endParaRPr lang="en-US"/>
           </a:p>
@@ -4109,7 +4216,7 @@
           <a:p>
             <a:fld id="{048E75BA-ABDE-473E-A6C9-CE8F4F15D8F3}" type="datetimeFigureOut">
               <a:rPr lang="en-US" smtClean="0"/>
-              <a:t>8/6/2021</a:t>
+              <a:t>8/23/2021</a:t>
             </a:fld>
             <a:endParaRPr lang="en-US"/>
           </a:p>
@@ -4420,7 +4527,7 @@
           <a:p>
             <a:fld id="{048E75BA-ABDE-473E-A6C9-CE8F4F15D8F3}" type="datetimeFigureOut">
               <a:rPr lang="en-US" smtClean="0"/>
-              <a:t>8/6/2021</a:t>
+              <a:t>8/23/2021</a:t>
             </a:fld>
             <a:endParaRPr lang="en-US"/>
           </a:p>
@@ -4708,7 +4815,7 @@
           <a:p>
             <a:fld id="{048E75BA-ABDE-473E-A6C9-CE8F4F15D8F3}" type="datetimeFigureOut">
               <a:rPr lang="en-US" smtClean="0"/>
-              <a:t>8/6/2021</a:t>
+              <a:t>8/23/2021</a:t>
             </a:fld>
             <a:endParaRPr lang="en-US"/>
           </a:p>
@@ -4949,7 +5056,7 @@
           <a:p>
             <a:fld id="{048E75BA-ABDE-473E-A6C9-CE8F4F15D8F3}" type="datetimeFigureOut">
               <a:rPr lang="en-US" smtClean="0"/>
-              <a:t>8/6/2021</a:t>
+              <a:t>8/23/2021</a:t>
             </a:fld>
             <a:endParaRPr lang="en-US"/>
           </a:p>
@@ -6752,7 +6859,7 @@
         </p:nvCxnSpPr>
         <p:spPr>
           <a:xfrm>
-            <a:off x="756324" y="3910373"/>
+            <a:off x="822826" y="4600120"/>
             <a:ext cx="10003339" cy="0"/>
           </a:xfrm>
           <a:prstGeom prst="line">
@@ -6789,7 +6896,7 @@
         <p:spPr>
           <a:xfrm>
             <a:off x="3771943" y="1368466"/>
-            <a:ext cx="2217274" cy="2800767"/>
+            <a:ext cx="2218108" cy="3662541"/>
           </a:xfrm>
           <a:prstGeom prst="rect">
             <a:avLst/>
@@ -6924,8 +7031,63 @@
                   <a:srgbClr val="00FF00"/>
                 </a:highlight>
               </a:rPr>
-              <a:t>sword</a:t>
-            </a:r>
+              <a:t>Sword</a:t>
+            </a:r>
+          </a:p>
+          <a:p>
+            <a:pPr marL="285750" indent="-285750">
+              <a:buFont typeface="Arial" panose="020B0604020202020204" pitchFamily="34" charset="0"/>
+              <a:buChar char="•"/>
+            </a:pPr>
+            <a:r>
+              <a:rPr lang="en-US" sz="1400" i="1" dirty="0" err="1">
+                <a:highlight>
+                  <a:srgbClr val="00FF00"/>
+                </a:highlight>
+              </a:rPr>
+              <a:t>FlagHasPicked</a:t>
+            </a:r>
+            <a:endParaRPr lang="en-US" sz="1400" i="1" dirty="0">
+              <a:highlight>
+                <a:srgbClr val="00FF00"/>
+              </a:highlight>
+            </a:endParaRPr>
+          </a:p>
+          <a:p>
+            <a:pPr marL="742950" lvl="1" indent="-285750">
+              <a:buFont typeface="Arial" panose="020B0604020202020204" pitchFamily="34" charset="0"/>
+              <a:buChar char="•"/>
+            </a:pPr>
+            <a:r>
+              <a:rPr lang="en-US" sz="1400" i="1" dirty="0">
+                <a:highlight>
+                  <a:srgbClr val="00FF00"/>
+                </a:highlight>
+              </a:rPr>
+              <a:t>Sword</a:t>
+            </a:r>
+          </a:p>
+          <a:p>
+            <a:pPr marL="742950" lvl="1" indent="-285750">
+              <a:buFont typeface="Arial" panose="020B0604020202020204" pitchFamily="34" charset="0"/>
+              <a:buChar char="•"/>
+            </a:pPr>
+            <a:endParaRPr lang="en-US" sz="1400" i="1" dirty="0">
+              <a:highlight>
+                <a:srgbClr val="00FF00"/>
+              </a:highlight>
+            </a:endParaRPr>
+          </a:p>
+          <a:p>
+            <a:pPr marL="742950" lvl="1" indent="-285750">
+              <a:buFont typeface="Arial" panose="020B0604020202020204" pitchFamily="34" charset="0"/>
+              <a:buChar char="•"/>
+            </a:pPr>
+            <a:endParaRPr lang="en-US" sz="1400" i="1" dirty="0">
+              <a:highlight>
+                <a:srgbClr val="00FF00"/>
+              </a:highlight>
+            </a:endParaRPr>
           </a:p>
           <a:p>
             <a:endParaRPr lang="en-US" dirty="0"/>
@@ -7053,13 +7215,18 @@
               <a:buChar char="•"/>
             </a:pPr>
             <a:r>
-              <a:rPr lang="en-US" sz="1400" i="1" dirty="0">
+              <a:rPr lang="en-US" sz="1400" i="1" dirty="0" err="1">
                 <a:highlight>
                   <a:srgbClr val="00FF00"/>
                 </a:highlight>
               </a:rPr>
-              <a:t>FlagPickedBy</a:t>
-            </a:r>
+              <a:t>FlagWasPickedBy</a:t>
+            </a:r>
+            <a:endParaRPr lang="en-US" sz="1400" i="1" dirty="0">
+              <a:highlight>
+                <a:srgbClr val="00FF00"/>
+              </a:highlight>
+            </a:endParaRPr>
           </a:p>
           <a:p>
             <a:pPr marL="742950" lvl="1" indent="-285750">
@@ -7613,7 +7780,7 @@
         <p:spPr>
           <a:xfrm>
             <a:off x="414987" y="876090"/>
-            <a:ext cx="6058646" cy="369332"/>
+            <a:ext cx="6129178" cy="369332"/>
           </a:xfrm>
           <a:prstGeom prst="rect">
             <a:avLst/>
@@ -7636,11 +7803,11 @@
             </a:r>
             <a:r>
               <a:rPr lang="en-US" dirty="0" err="1"/>
-              <a:t>PickUped</a:t>
+              <a:t>PickUp</a:t>
             </a:r>
             <a:r>
               <a:rPr lang="en-US" dirty="0"/>
-              <a:t> sword processed by Arm weapon system – 1</a:t>
+              <a:t>-ed sword processed by Arm weapon system – 1</a:t>
             </a:r>
             <a:r>
               <a:rPr lang="en-US" baseline="30000" dirty="0"/>
@@ -7986,13 +8153,18 @@
               <a:buChar char="•"/>
             </a:pPr>
             <a:r>
-              <a:rPr lang="en-US" sz="1400" i="1" dirty="0">
+              <a:rPr lang="en-US" sz="1400" i="1" dirty="0" err="1">
                 <a:highlight>
                   <a:srgbClr val="FFFF00"/>
                 </a:highlight>
               </a:rPr>
-              <a:t>FlagPickedBy</a:t>
-            </a:r>
+              <a:t>FlagWasPickedBy</a:t>
+            </a:r>
+            <a:endParaRPr lang="en-US" sz="1400" i="1" dirty="0">
+              <a:highlight>
+                <a:srgbClr val="FFFF00"/>
+              </a:highlight>
+            </a:endParaRPr>
           </a:p>
           <a:p>
             <a:pPr marL="742950" lvl="1" indent="-285750">
@@ -9422,7 +9594,7 @@
         <p:spPr>
           <a:xfrm>
             <a:off x="414987" y="876090"/>
-            <a:ext cx="5927648" cy="369332"/>
+            <a:ext cx="5998180" cy="369332"/>
           </a:xfrm>
           <a:prstGeom prst="rect">
             <a:avLst/>
@@ -9445,11 +9617,11 @@
             </a:r>
             <a:r>
               <a:rPr lang="en-US" dirty="0" err="1"/>
-              <a:t>PickUped</a:t>
+              <a:t>PickUp</a:t>
             </a:r>
             <a:r>
               <a:rPr lang="en-US" dirty="0"/>
-              <a:t> sword processed by Arm Ammo system – 1</a:t>
+              <a:t>-ed sword processed by Arm Ammo system – 1</a:t>
             </a:r>
             <a:r>
               <a:rPr lang="en-US" baseline="30000" dirty="0"/>
@@ -9815,13 +9987,18 @@
               <a:buChar char="•"/>
             </a:pPr>
             <a:r>
-              <a:rPr lang="en-US" sz="1400" i="1" dirty="0">
+              <a:rPr lang="en-US" sz="1400" i="1" dirty="0" err="1">
                 <a:highlight>
                   <a:srgbClr val="FFFF00"/>
                 </a:highlight>
               </a:rPr>
-              <a:t>FlagPickedBy</a:t>
-            </a:r>
+              <a:t>FlagWasPickedBy</a:t>
+            </a:r>
+            <a:endParaRPr lang="en-US" sz="1400" i="1" dirty="0">
+              <a:highlight>
+                <a:srgbClr val="FFFF00"/>
+              </a:highlight>
+            </a:endParaRPr>
           </a:p>
           <a:p>
             <a:pPr marL="742950" lvl="1" indent="-285750">
@@ -11672,9 +11849,10 @@
               <a:buChar char="•"/>
             </a:pPr>
             <a:r>
-              <a:rPr lang="en-US" sz="1400" i="1" dirty="0"/>
-              <a:t>FlagPickedBy</a:t>
-            </a:r>
+              <a:rPr lang="en-US" sz="1400" i="1" dirty="0" err="1"/>
+              <a:t>FlagWasPickedBy</a:t>
+            </a:r>
+            <a:endParaRPr lang="en-US" sz="1400" i="1" dirty="0"/>
           </a:p>
           <a:p>
             <a:pPr marL="742950" lvl="1" indent="-285750">
@@ -13640,9 +13818,10 @@
               <a:buChar char="•"/>
             </a:pPr>
             <a:r>
-              <a:rPr lang="en-US" sz="1400" i="1" dirty="0"/>
-              <a:t>FlagPickedBy</a:t>
-            </a:r>
+              <a:rPr lang="en-US" sz="1400" i="1" dirty="0" err="1"/>
+              <a:t>FlagWasPickedBy</a:t>
+            </a:r>
+            <a:endParaRPr lang="en-US" sz="1400" i="1" dirty="0"/>
           </a:p>
           <a:p>
             <a:pPr marL="742950" lvl="1" indent="-285750">

</xml_diff>